<commit_message>
docs: simplify executive deck language and add method examples
- Replace jargon (centroid construction, fingerprint construction, label propagation)
  with plain executive-friendly language across slides 2, 4, and 5
- Add short concrete examples for each of the 3 classification methods
- Replace "on unanimous panel recipes" with "on recipes where all 4 panelists agreed"
- Clarify that Expert Scoring can reduce to a single label by taking the highest score
</commit_message>
<xml_diff>
--- a/outputs/TAIsty_Executive_Update_July2026.pptx
+++ b/outputs/TAIsty_Executive_Update_July2026.pptx
@@ -6086,15 +6086,14 @@
           <a:p>
             <a:pPr algn="ctr"/>
             <a:r>
-              <a:rPr sz="850" b="0" i="0">
+              <a:rPr b="0" sz="850">
                 <a:solidFill>
                   <a:srgbClr val="FFFFFF"/>
                 </a:solidFill>
-                <a:latin typeface="Calibri"/>
               </a:rPr>
               <a:t>Only panel-confirmed
 recipes used to build
-final fingerprints</a:t>
+final ingredient profiles</a:t>
             </a:r>
           </a:p>
         </p:txBody>
@@ -6452,13 +6451,12 @@
           <a:p>
             <a:pPr algn="l"/>
             <a:r>
-              <a:rPr sz="1050" b="1" i="0">
+              <a:rPr b="1" sz="1050">
                 <a:solidFill>
                   <a:srgbClr val="2C3E50"/>
                 </a:solidFill>
-                <a:latin typeface="Calibri"/>
-              </a:rPr>
-              <a:t>Outlier-Resistant Centroid Construction</a:t>
+              </a:rPr>
+              <a:t>Building a Reference Recipe for Each Flavor Type</a:t>
             </a:r>
           </a:p>
         </p:txBody>
@@ -6487,13 +6485,12 @@
           <a:p>
             <a:pPr algn="l"/>
             <a:r>
-              <a:rPr sz="950" b="0" i="0">
+              <a:rPr b="0" sz="950">
                 <a:solidFill>
                   <a:srgbClr val="666666"/>
                 </a:solidFill>
-                <a:latin typeface="Calibri"/>
-              </a:rPr>
-              <a:t>Cluster reference points are built using the element-wise median of target recipes rather than the mean, making them robust to single-ingredient outliers. An additional contrast step removes shared background notes that appear across all clusters, so each archetype is defined by what makes it distinctive.</a:t>
+              </a:rPr>
+              <a:t>For each flavor type, we define a reference recipe based on the typical ingredient amounts from panel-confirmed examples. This ensures each type is defined by what makes it truly distinctive, not by what all recipes share in common.</a:t>
             </a:r>
           </a:p>
         </p:txBody>
@@ -6647,13 +6644,12 @@
           <a:p>
             <a:pPr algn="l"/>
             <a:r>
-              <a:rPr sz="950" b="0" i="0">
+              <a:rPr b="0" sz="950">
                 <a:solidFill>
                   <a:srgbClr val="666666"/>
                 </a:solidFill>
-                <a:latin typeface="Calibri"/>
-              </a:rPr>
-              <a:t>Recipes where our two classification methods disagree, or where the sensory panel returned a split verdict, are flagged and excluded from fingerprint construction. This iterative loop, classify then taste then refine, progressively improves the quality of cluster definitions over time.</a:t>
+              </a:rPr>
+              <a:t>Recipes where our two classification methods disagree, or where the sensory panel returned a split verdict, are flagged and excluded when building the ingredient profiles. This iterative loop, classify then taste then refine, progressively improves the quality of cluster definitions over time.</a:t>
             </a:r>
           </a:p>
         </p:txBody>
@@ -6807,13 +6803,12 @@
           <a:p>
             <a:pPr algn="l"/>
             <a:r>
-              <a:rPr sz="1000" b="0" i="0">
+              <a:rPr b="0" sz="1000">
                 <a:solidFill>
                   <a:srgbClr val="2C3E50"/>
                 </a:solidFill>
-                <a:latin typeface="Calibri"/>
-              </a:rPr>
-              <a:t>Running statistical fingerprint analysis only on panel-confirmed recipes produces sharper ingredient profiles than using all available data indiscriminately. Fewer noise recipes in the reference set means more reliable formulation proposals. The quality of our first formulation is directly tied to the quality of our input labels.</a:t>
+              </a:rPr>
+              <a:t>Analyzing only panel-confirmed recipes produces clearer ingredient profiles and more reliable formulation proposals. The better our input labels, the better our first formulation.</a:t>
             </a:r>
           </a:p>
         </p:txBody>
@@ -9212,13 +9207,12 @@
           <a:p>
             <a:pPr algn="l"/>
             <a:r>
-              <a:rPr sz="800" b="1" i="0">
+              <a:rPr b="1" sz="800">
                 <a:solidFill>
                   <a:srgbClr val="AABBCC"/>
                 </a:solidFill>
-                <a:latin typeface="Calibri"/>
-              </a:rPr>
-              <a:t>04 / FROM FINGERPRINTS TO SCORES</a:t>
+              </a:rPr>
+              <a:t>04 / FROM INGREDIENT ANALYSIS TO SCORING</a:t>
             </a:r>
           </a:p>
         </p:txBody>
@@ -9247,13 +9241,12 @@
           <a:p>
             <a:pPr algn="l"/>
             <a:r>
-              <a:rPr sz="2600" b="1" i="0">
+              <a:rPr b="1" sz="2600">
                 <a:solidFill>
                   <a:srgbClr val="FFFFFF"/>
                 </a:solidFill>
-                <a:latin typeface="Calibri"/>
-              </a:rPr>
-              <a:t>Statistical Analysis Informing Expert Weight Definitions</a:t>
+              </a:rPr>
+              <a:t>How ingredient analysis guided the design of the scoring system</a:t>
             </a:r>
           </a:p>
         </p:txBody>
@@ -9282,13 +9275,12 @@
           <a:p>
             <a:pPr algn="l"/>
             <a:r>
-              <a:rPr sz="1100" b="0" i="1">
+              <a:rPr b="0" sz="1100">
                 <a:solidFill>
                   <a:srgbClr val="CCDDEE"/>
                 </a:solidFill>
-                <a:latin typeface="Calibri"/>
-              </a:rPr>
-              <a:t>How per-cluster ingredient analysis guided the design of the scoring framework</a:t>
+              </a:rPr>
+              <a:t>Per-flavor-type ingredient analysis, panel-verified recipes only</a:t>
             </a:r>
           </a:p>
         </p:txBody>
@@ -11141,7 +11133,7 @@
                 </a:solidFill>
                 <a:latin typeface="Calibri"/>
               </a:rPr>
-              <a:t>on unanimous panel recipes</a:t>
+              <a:t>on recipes where all 4 panelists agreed</a:t>
             </a:r>
           </a:p>
         </p:txBody>
@@ -11177,6 +11169,17 @@
                 <a:latin typeface="Calibri"/>
               </a:rPr>
               <a:t>Transparent and auditable. Every decision can be traced back to a specific flavorist rule. Rules are maintained directly by the flavor team and take effect immediately.</a:t>
+            </a:r>
+          </a:p>
+          <a:p/>
+          <a:p>
+            <a:r>
+              <a:rPr sz="750" i="1">
+                <a:solidFill>
+                  <a:srgbClr val="888888"/>
+                </a:solidFill>
+              </a:rPr>
+              <a:t>"If it smells strongly of caramel and jam → it's Warm."</a:t>
             </a:r>
           </a:p>
         </p:txBody>
@@ -11295,31 +11298,12 @@
           <a:p>
             <a:pPr algn="l"/>
             <a:r>
-              <a:rPr sz="1100" b="1" i="0" dirty="0">
+              <a:rPr b="1" sz="1100">
                 <a:solidFill>
                   <a:srgbClr val="FFFFFF"/>
                 </a:solidFill>
-                <a:latin typeface="Calibri"/>
-              </a:rPr>
-              <a:t>Statistical </a:t>
-            </a:r>
-            <a:r>
-              <a:rPr lang="de-DE" sz="1100" b="1">
-                <a:solidFill>
-                  <a:srgbClr val="FFFFFF"/>
-                </a:solidFill>
-                <a:latin typeface="Calibri"/>
-              </a:rPr>
-              <a:t>-</a:t>
-            </a:r>
-            <a:r>
-              <a:rPr sz="1100" b="1" i="0" dirty="0">
-                <a:solidFill>
-                  <a:srgbClr val="FFFFFF"/>
-                </a:solidFill>
-                <a:latin typeface="Calibri"/>
-              </a:rPr>
-              <a:t> Label Propagation</a:t>
+              </a:rPr>
+              <a:t>Statistical - Similarity-Based Classification</a:t>
             </a:r>
           </a:p>
         </p:txBody>
@@ -11389,7 +11373,7 @@
                 </a:solidFill>
                 <a:latin typeface="Calibri"/>
               </a:rPr>
-              <a:t>on unanimous panel recipes</a:t>
+              <a:t>on recipes where all 4 panelists agreed</a:t>
             </a:r>
           </a:p>
         </p:txBody>
@@ -11418,13 +11402,23 @@
           <a:p>
             <a:pPr algn="l"/>
             <a:r>
-              <a:rPr sz="900" b="0" i="0">
+              <a:rPr b="0" sz="900">
                 <a:solidFill>
                   <a:srgbClr val="666666"/>
                 </a:solidFill>
-                <a:latin typeface="Calibri"/>
-              </a:rPr>
-              <a:t>Graph-based similarity propagation from expert anchor recipes. Captures the full ingredient neighborhood context for borderline cases without assuming uniform cluster shapes.</a:t>
+              </a:rPr>
+              <a:t>Flavorist-confirmed recipes anchor the system. Every other recipe is classified by how similar it is to those anchors, making it well-suited for borderline cases.</a:t>
+            </a:r>
+          </a:p>
+          <a:p/>
+          <a:p>
+            <a:r>
+              <a:rPr sz="750" i="1">
+                <a:solidFill>
+                  <a:srgbClr val="888888"/>
+                </a:solidFill>
+              </a:rPr>
+              <a:t>"This new recipe looks most like the ones we already know are Green."</a:t>
             </a:r>
           </a:p>
         </p:txBody>
@@ -11640,6 +11634,17 @@
               <a:t>A continuous weighted scoring system assigns each recipe a profile across all 7 archetypes, revealing degree of membership rather than a binary label. Active calibration of ingredient weights is underway with flavor experts.</a:t>
             </a:r>
           </a:p>
+          <a:p/>
+          <a:p>
+            <a:r>
+              <a:rPr sz="750" i="1">
+                <a:solidFill>
+                  <a:srgbClr val="888888"/>
+                </a:solidFill>
+              </a:rPr>
+              <a:t>"This recipe is 80% Warm, 15% Green, 5% Floral." If a single label is needed, we simply pick the highest score — Warm in this case.</a:t>
+            </a:r>
+          </a:p>
         </p:txBody>
       </p:sp>
       <p:sp>
@@ -11995,13 +12000,12 @@
           <a:p>
             <a:pPr algn="l"/>
             <a:r>
-              <a:rPr sz="1100" b="1" i="0">
+              <a:rPr b="1" sz="1100">
                 <a:solidFill>
                   <a:srgbClr val="2C3E50"/>
                 </a:solidFill>
-                <a:latin typeface="Calibri"/>
-              </a:rPr>
-              <a:t>1.  Finalize Expert Scoring Calibration</a:t>
+              </a:rPr>
+              <a:t>1.  Fine-tune the scoring system</a:t>
             </a:r>
           </a:p>
         </p:txBody>
@@ -12030,13 +12034,12 @@
           <a:p>
             <a:pPr algn="l"/>
             <a:r>
-              <a:rPr sz="950" b="0" i="0">
+              <a:rPr b="0" sz="950">
                 <a:solidFill>
                   <a:srgbClr val="666666"/>
                 </a:solidFill>
-                <a:latin typeface="Calibri"/>
-              </a:rPr>
-              <a:t>Align ingredient weight scales across all archetypes and add missing signature compounds. Accuracy will be re-evaluated once calibration is complete.</a:t>
+              </a:rPr>
+              <a:t>Align ingredient weights with flavorist expertise and fill in missing signature compounds.</a:t>
             </a:r>
           </a:p>
         </p:txBody>
@@ -12155,13 +12158,12 @@
           <a:p>
             <a:pPr algn="l"/>
             <a:r>
-              <a:rPr sz="1100" b="1" i="0">
+              <a:rPr b="1" sz="1100">
                 <a:solidFill>
                   <a:srgbClr val="2C3E50"/>
                 </a:solidFill>
-                <a:latin typeface="Calibri"/>
-              </a:rPr>
-              <a:t>2.  Define Archetype Building Blocks</a:t>
+              </a:rPr>
+              <a:t>2.  Define the key ingredients per flavor type</a:t>
             </a:r>
           </a:p>
         </p:txBody>
@@ -12190,13 +12192,12 @@
           <a:p>
             <a:pPr algn="l"/>
             <a:r>
-              <a:rPr sz="950" b="0" i="0">
+              <a:rPr b="0" sz="950">
                 <a:solidFill>
                   <a:srgbClr val="666666"/>
                 </a:solidFill>
-                <a:latin typeface="Calibri"/>
-              </a:rPr>
-              <a:t>Encode the top characteristic ingredients per archetype as reusable building blocks for the first automated formulation proposals.</a:t>
+              </a:rPr>
+              <a:t>Lock in the top characteristic ingredients for each flavor type, ready to use in new formulations.</a:t>
             </a:r>
           </a:p>
         </p:txBody>
@@ -12315,13 +12316,12 @@
           <a:p>
             <a:pPr algn="l"/>
             <a:r>
-              <a:rPr sz="1100" b="1" i="0">
+              <a:rPr b="1" sz="1100">
                 <a:solidFill>
                   <a:srgbClr val="2C3E50"/>
                 </a:solidFill>
-                <a:latin typeface="Calibri"/>
-              </a:rPr>
-              <a:t>3.  End-to-End Strawberry Prototype</a:t>
+              </a:rPr>
+              <a:t>3.  Build the first working prototype</a:t>
             </a:r>
           </a:p>
         </p:txBody>

</xml_diff>